<commit_message>
Remove the itemised inclusions from both options
Scope is not settled, so the line-item breakdown is removed from Option A
and Option B. Each option now shows its total, its payment terms and
"Inclusions to be confirmed".

Carried through the markdown, the docx, the deck and the page. The deck
stopped parsing the four line fees it no longer prints, so a figure it
cannot show can no longer break the build. The Option A payment note lost
its closing clause, which described line fees that are no longer there.

Co-Authored-By: Claude Opus 5 <noreply@anthropic.com>
Claude-Session: https://claude.ai/code/session_01Asjqk2CJhNThgugfeWzXnb
</commit_message>
<xml_diff>
--- a/00 Admin/04 Commercial + SOW/JP_TapThat_ProposalDeck_v03.pptx
+++ b/00 Admin/04 Commercial + SOW/JP_TapThat_ProposalDeck_v03.pptx
@@ -15571,7 +15571,7 @@
         </p:nvGraphicFramePr>
         <p:xfrm>
           <a:off x="914400" y="2880360"/>
-          <a:ext cx="10362894" cy="2507772"/>
+          <a:ext cx="10362894" cy="832683"/>
         </p:xfrm>
         <a:graphic>
           <a:graphicData uri="http://schemas.openxmlformats.org/drawingml/2006/table">
@@ -15647,282 +15647,6 @@
                           <a:latin typeface="Poppins"/>
                         </a:rPr>
                         <a:t>FEE</a:t>
-                      </a:r>
-                    </a:p>
-                  </a:txBody>
-                  <a:tcPr marL="0" marR="128016" marT="36576" marB="54864" anchor="t">
-                    <a:lnB w="9525" cap="flat" cmpd="sng" algn="ctr">
-                      <a:solidFill>
-                        <a:srgbClr val="D4D2D0"/>
-                      </a:solidFill>
-                    </a:lnB>
-                    <a:lnT w="0" cap="flat" cmpd="sng" algn="ctr">
-                      <a:solidFill>
-                        <a:srgbClr val="FAF8F4"/>
-                      </a:solidFill>
-                    </a:lnT>
-                    <a:lnR w="0" cap="flat" cmpd="sng" algn="ctr">
-                      <a:solidFill>
-                        <a:srgbClr val="FAF8F4"/>
-                      </a:solidFill>
-                    </a:lnR>
-                    <a:lnL w="0" cap="flat" cmpd="sng" algn="ctr">
-                      <a:solidFill>
-                        <a:srgbClr val="FAF8F4"/>
-                      </a:solidFill>
-                    </a:lnL>
-                    <a:noFill/>
-                  </a:tcPr>
-                </a:tc>
-              </a:tr>
-              <a:tr h="558363">
-                <a:tc>
-                  <a:txBody>
-                    <a:bodyPr wrap="square"/>
-                    <a:lstStyle/>
-                    <a:p>
-                      <a:pPr>
-                        <a:lnSpc>
-                          <a:spcPct val="134000"/>
-                        </a:lnSpc>
-                      </a:pPr>
-                      <a:r>
-                        <a:rPr sz="1100" b="1">
-                          <a:solidFill>
-                            <a:srgbClr val="111111"/>
-                          </a:solidFill>
-                          <a:latin typeface="Poppins"/>
-                        </a:rPr>
-                        <a:t>Foundation builds. Website rebuild with the buy path and proof pages, SEM set-up, trigger-based CRM with segments, three campaign landing pages</a:t>
-                      </a:r>
-                    </a:p>
-                  </a:txBody>
-                  <a:tcPr marL="0" marR="128016" marT="36576" marB="54864" anchor="t">
-                    <a:lnB w="9525" cap="flat" cmpd="sng" algn="ctr">
-                      <a:solidFill>
-                        <a:srgbClr val="D4D2D0"/>
-                      </a:solidFill>
-                    </a:lnB>
-                    <a:lnT w="0" cap="flat" cmpd="sng" algn="ctr">
-                      <a:solidFill>
-                        <a:srgbClr val="FAF8F4"/>
-                      </a:solidFill>
-                    </a:lnT>
-                    <a:lnR w="0" cap="flat" cmpd="sng" algn="ctr">
-                      <a:solidFill>
-                        <a:srgbClr val="FAF8F4"/>
-                      </a:solidFill>
-                    </a:lnR>
-                    <a:lnL w="0" cap="flat" cmpd="sng" algn="ctr">
-                      <a:solidFill>
-                        <a:srgbClr val="FAF8F4"/>
-                      </a:solidFill>
-                    </a:lnL>
-                    <a:noFill/>
-                  </a:tcPr>
-                </a:tc>
-                <a:tc>
-                  <a:txBody>
-                    <a:bodyPr wrap="square"/>
-                    <a:lstStyle/>
-                    <a:p>
-                      <a:pPr>
-                        <a:lnSpc>
-                          <a:spcPct val="134000"/>
-                        </a:lnSpc>
-                      </a:pPr>
-                      <a:r>
-                        <a:rPr sz="1100" b="0">
-                          <a:solidFill>
-                            <a:srgbClr val="111111"/>
-                          </a:solidFill>
-                          <a:latin typeface="Poppins"/>
-                        </a:rPr>
-                        <a:t>$9,250</a:t>
-                      </a:r>
-                    </a:p>
-                  </a:txBody>
-                  <a:tcPr marL="0" marR="128016" marT="36576" marB="54864" anchor="t">
-                    <a:lnB w="9525" cap="flat" cmpd="sng" algn="ctr">
-                      <a:solidFill>
-                        <a:srgbClr val="D4D2D0"/>
-                      </a:solidFill>
-                    </a:lnB>
-                    <a:lnT w="0" cap="flat" cmpd="sng" algn="ctr">
-                      <a:solidFill>
-                        <a:srgbClr val="FAF8F4"/>
-                      </a:solidFill>
-                    </a:lnT>
-                    <a:lnR w="0" cap="flat" cmpd="sng" algn="ctr">
-                      <a:solidFill>
-                        <a:srgbClr val="FAF8F4"/>
-                      </a:solidFill>
-                    </a:lnR>
-                    <a:lnL w="0" cap="flat" cmpd="sng" algn="ctr">
-                      <a:solidFill>
-                        <a:srgbClr val="FAF8F4"/>
-                      </a:solidFill>
-                    </a:lnL>
-                    <a:noFill/>
-                  </a:tcPr>
-                </a:tc>
-              </a:tr>
-              <a:tr h="558363">
-                <a:tc>
-                  <a:txBody>
-                    <a:bodyPr wrap="square"/>
-                    <a:lstStyle/>
-                    <a:p>
-                      <a:pPr>
-                        <a:lnSpc>
-                          <a:spcPct val="134000"/>
-                        </a:lnSpc>
-                      </a:pPr>
-                      <a:r>
-                        <a:rPr sz="1100" b="1">
-                          <a:solidFill>
-                            <a:srgbClr val="111111"/>
-                          </a:solidFill>
-                          <a:latin typeface="Poppins"/>
-                        </a:rPr>
-                        <a:t>Program design. Switcher offer and partner approach, referral program, wholesale structure and hire brief, key messaging and the customer journey, the competition campaign</a:t>
-                      </a:r>
-                    </a:p>
-                  </a:txBody>
-                  <a:tcPr marL="0" marR="128016" marT="36576" marB="54864" anchor="t">
-                    <a:lnB w="9525" cap="flat" cmpd="sng" algn="ctr">
-                      <a:solidFill>
-                        <a:srgbClr val="D4D2D0"/>
-                      </a:solidFill>
-                    </a:lnB>
-                    <a:lnT w="0" cap="flat" cmpd="sng" algn="ctr">
-                      <a:solidFill>
-                        <a:srgbClr val="FAF8F4"/>
-                      </a:solidFill>
-                    </a:lnT>
-                    <a:lnR w="0" cap="flat" cmpd="sng" algn="ctr">
-                      <a:solidFill>
-                        <a:srgbClr val="FAF8F4"/>
-                      </a:solidFill>
-                    </a:lnR>
-                    <a:lnL w="0" cap="flat" cmpd="sng" algn="ctr">
-                      <a:solidFill>
-                        <a:srgbClr val="FAF8F4"/>
-                      </a:solidFill>
-                    </a:lnL>
-                    <a:noFill/>
-                  </a:tcPr>
-                </a:tc>
-                <a:tc>
-                  <a:txBody>
-                    <a:bodyPr wrap="square"/>
-                    <a:lstStyle/>
-                    <a:p>
-                      <a:pPr>
-                        <a:lnSpc>
-                          <a:spcPct val="134000"/>
-                        </a:lnSpc>
-                      </a:pPr>
-                      <a:r>
-                        <a:rPr sz="1100" b="0">
-                          <a:solidFill>
-                            <a:srgbClr val="111111"/>
-                          </a:solidFill>
-                          <a:latin typeface="Poppins"/>
-                        </a:rPr>
-                        <a:t>$8,500</a:t>
-                      </a:r>
-                    </a:p>
-                  </a:txBody>
-                  <a:tcPr marL="0" marR="128016" marT="36576" marB="54864" anchor="t">
-                    <a:lnB w="9525" cap="flat" cmpd="sng" algn="ctr">
-                      <a:solidFill>
-                        <a:srgbClr val="D4D2D0"/>
-                      </a:solidFill>
-                    </a:lnB>
-                    <a:lnT w="0" cap="flat" cmpd="sng" algn="ctr">
-                      <a:solidFill>
-                        <a:srgbClr val="FAF8F4"/>
-                      </a:solidFill>
-                    </a:lnT>
-                    <a:lnR w="0" cap="flat" cmpd="sng" algn="ctr">
-                      <a:solidFill>
-                        <a:srgbClr val="FAF8F4"/>
-                      </a:solidFill>
-                    </a:lnR>
-                    <a:lnL w="0" cap="flat" cmpd="sng" algn="ctr">
-                      <a:solidFill>
-                        <a:srgbClr val="FAF8F4"/>
-                      </a:solidFill>
-                    </a:lnL>
-                    <a:noFill/>
-                  </a:tcPr>
-                </a:tc>
-              </a:tr>
-              <a:tr h="558363">
-                <a:tc>
-                  <a:txBody>
-                    <a:bodyPr wrap="square"/>
-                    <a:lstStyle/>
-                    <a:p>
-                      <a:pPr>
-                        <a:lnSpc>
-                          <a:spcPct val="134000"/>
-                        </a:lnSpc>
-                      </a:pPr>
-                      <a:r>
-                        <a:rPr sz="1100" b="1">
-                          <a:solidFill>
-                            <a:srgbClr val="111111"/>
-                          </a:solidFill>
-                          <a:latin typeface="Poppins"/>
-                        </a:rPr>
-                        <a:t>Running the sprint, three months. SEM and Meta management, JVP and wholesale outreach, content and artwork, the rhythm and the report</a:t>
-                      </a:r>
-                    </a:p>
-                  </a:txBody>
-                  <a:tcPr marL="0" marR="128016" marT="36576" marB="54864" anchor="t">
-                    <a:lnB w="9525" cap="flat" cmpd="sng" algn="ctr">
-                      <a:solidFill>
-                        <a:srgbClr val="D4D2D0"/>
-                      </a:solidFill>
-                    </a:lnB>
-                    <a:lnT w="0" cap="flat" cmpd="sng" algn="ctr">
-                      <a:solidFill>
-                        <a:srgbClr val="FAF8F4"/>
-                      </a:solidFill>
-                    </a:lnT>
-                    <a:lnR w="0" cap="flat" cmpd="sng" algn="ctr">
-                      <a:solidFill>
-                        <a:srgbClr val="FAF8F4"/>
-                      </a:solidFill>
-                    </a:lnR>
-                    <a:lnL w="0" cap="flat" cmpd="sng" algn="ctr">
-                      <a:solidFill>
-                        <a:srgbClr val="FAF8F4"/>
-                      </a:solidFill>
-                    </a:lnL>
-                    <a:noFill/>
-                  </a:tcPr>
-                </a:tc>
-                <a:tc>
-                  <a:txBody>
-                    <a:bodyPr wrap="square"/>
-                    <a:lstStyle/>
-                    <a:p>
-                      <a:pPr>
-                        <a:lnSpc>
-                          <a:spcPct val="134000"/>
-                        </a:lnSpc>
-                      </a:pPr>
-                      <a:r>
-                        <a:rPr sz="1100" b="0">
-                          <a:solidFill>
-                            <a:srgbClr val="111111"/>
-                          </a:solidFill>
-                          <a:latin typeface="Poppins"/>
-                        </a:rPr>
-                        <a:t>$3,250 a month, $9,750</a:t>
                       </a:r>
                     </a:p>
                   </a:txBody>
@@ -16082,7 +15806,7 @@
                 </a:solidFill>
                 <a:latin typeface="Poppins"/>
               </a:rPr>
-              <a:t>$25,000 on acceptance, or $8,333 a month across the three months. Stop or continue at the mid-December review. The line fees are the standard rate and sum to $27,500; the discount is applied to the total.</a:t>
+              <a:t>$25,000 on acceptance, or $8,333 a month across the three months. Stop or continue at the mid-December review. Inclusions to be confirmed.</a:t>
             </a:r>
           </a:p>
         </p:txBody>
@@ -16240,7 +15964,7 @@
         </p:nvGraphicFramePr>
         <p:xfrm>
           <a:off x="914400" y="2880360"/>
-          <a:ext cx="10362894" cy="2177789"/>
+          <a:ext cx="10362894" cy="1061064"/>
         </p:xfrm>
         <a:graphic>
           <a:graphicData uri="http://schemas.openxmlformats.org/drawingml/2006/table">
@@ -16316,190 +16040,6 @@
                           <a:latin typeface="Poppins"/>
                         </a:rPr>
                         <a:t>FEE</a:t>
-                      </a:r>
-                    </a:p>
-                  </a:txBody>
-                  <a:tcPr marL="0" marR="128016" marT="36576" marB="54864" anchor="t">
-                    <a:lnB w="9525" cap="flat" cmpd="sng" algn="ctr">
-                      <a:solidFill>
-                        <a:srgbClr val="D4D2D0"/>
-                      </a:solidFill>
-                    </a:lnB>
-                    <a:lnT w="0" cap="flat" cmpd="sng" algn="ctr">
-                      <a:solidFill>
-                        <a:srgbClr val="FAF8F4"/>
-                      </a:solidFill>
-                    </a:lnT>
-                    <a:lnR w="0" cap="flat" cmpd="sng" algn="ctr">
-                      <a:solidFill>
-                        <a:srgbClr val="FAF8F4"/>
-                      </a:solidFill>
-                    </a:lnR>
-                    <a:lnL w="0" cap="flat" cmpd="sng" algn="ctr">
-                      <a:solidFill>
-                        <a:srgbClr val="FAF8F4"/>
-                      </a:solidFill>
-                    </a:lnL>
-                    <a:noFill/>
-                  </a:tcPr>
-                </a:tc>
-              </a:tr>
-              <a:tr h="329981">
-                <a:tc>
-                  <a:txBody>
-                    <a:bodyPr wrap="square"/>
-                    <a:lstStyle/>
-                    <a:p>
-                      <a:pPr>
-                        <a:lnSpc>
-                          <a:spcPct val="134000"/>
-                        </a:lnSpc>
-                      </a:pPr>
-                      <a:r>
-                        <a:rPr sz="1100" b="1">
-                          <a:solidFill>
-                            <a:srgbClr val="111111"/>
-                          </a:solidFill>
-                          <a:latin typeface="Poppins"/>
-                        </a:rPr>
-                        <a:t>Everything in Option A, delivered in the first three months</a:t>
-                      </a:r>
-                    </a:p>
-                  </a:txBody>
-                  <a:tcPr marL="0" marR="128016" marT="36576" marB="54864" anchor="t">
-                    <a:lnB w="9525" cap="flat" cmpd="sng" algn="ctr">
-                      <a:solidFill>
-                        <a:srgbClr val="D4D2D0"/>
-                      </a:solidFill>
-                    </a:lnB>
-                    <a:lnT w="0" cap="flat" cmpd="sng" algn="ctr">
-                      <a:solidFill>
-                        <a:srgbClr val="FAF8F4"/>
-                      </a:solidFill>
-                    </a:lnT>
-                    <a:lnR w="0" cap="flat" cmpd="sng" algn="ctr">
-                      <a:solidFill>
-                        <a:srgbClr val="FAF8F4"/>
-                      </a:solidFill>
-                    </a:lnR>
-                    <a:lnL w="0" cap="flat" cmpd="sng" algn="ctr">
-                      <a:solidFill>
-                        <a:srgbClr val="FAF8F4"/>
-                      </a:solidFill>
-                    </a:lnL>
-                    <a:noFill/>
-                  </a:tcPr>
-                </a:tc>
-                <a:tc>
-                  <a:txBody>
-                    <a:bodyPr wrap="square"/>
-                    <a:lstStyle/>
-                    <a:p>
-                      <a:pPr>
-                        <a:lnSpc>
-                          <a:spcPct val="134000"/>
-                        </a:lnSpc>
-                      </a:pPr>
-                      <a:r>
-                        <a:rPr sz="1100" b="0">
-                          <a:solidFill>
-                            <a:srgbClr val="111111"/>
-                          </a:solidFill>
-                          <a:latin typeface="Poppins"/>
-                        </a:rPr>
-                        <a:t>Included</a:t>
-                      </a:r>
-                    </a:p>
-                  </a:txBody>
-                  <a:tcPr marL="0" marR="128016" marT="36576" marB="54864" anchor="t">
-                    <a:lnB w="9525" cap="flat" cmpd="sng" algn="ctr">
-                      <a:solidFill>
-                        <a:srgbClr val="D4D2D0"/>
-                      </a:solidFill>
-                    </a:lnB>
-                    <a:lnT w="0" cap="flat" cmpd="sng" algn="ctr">
-                      <a:solidFill>
-                        <a:srgbClr val="FAF8F4"/>
-                      </a:solidFill>
-                    </a:lnT>
-                    <a:lnR w="0" cap="flat" cmpd="sng" algn="ctr">
-                      <a:solidFill>
-                        <a:srgbClr val="FAF8F4"/>
-                      </a:solidFill>
-                    </a:lnR>
-                    <a:lnL w="0" cap="flat" cmpd="sng" algn="ctr">
-                      <a:solidFill>
-                        <a:srgbClr val="FAF8F4"/>
-                      </a:solidFill>
-                    </a:lnL>
-                    <a:noFill/>
-                  </a:tcPr>
-                </a:tc>
-              </a:tr>
-              <a:tr h="786744">
-                <a:tc>
-                  <a:txBody>
-                    <a:bodyPr wrap="square"/>
-                    <a:lstStyle/>
-                    <a:p>
-                      <a:pPr>
-                        <a:lnSpc>
-                          <a:spcPct val="134000"/>
-                        </a:lnSpc>
-                      </a:pPr>
-                      <a:r>
-                        <a:rPr sz="1100" b="1">
-                          <a:solidFill>
-                            <a:srgbClr val="111111"/>
-                          </a:solidFill>
-                          <a:latin typeface="Poppins"/>
-                        </a:rPr>
-                        <a:t>Months four to twelve. Weddings and functions, party rental reworked, the membership redesign when you release it, range and hero marketing, club and venue offers, SEM, outreach, content and artwork continuing, the reviews at March and September</a:t>
-                      </a:r>
-                    </a:p>
-                  </a:txBody>
-                  <a:tcPr marL="0" marR="128016" marT="36576" marB="54864" anchor="t">
-                    <a:lnB w="9525" cap="flat" cmpd="sng" algn="ctr">
-                      <a:solidFill>
-                        <a:srgbClr val="D4D2D0"/>
-                      </a:solidFill>
-                    </a:lnB>
-                    <a:lnT w="0" cap="flat" cmpd="sng" algn="ctr">
-                      <a:solidFill>
-                        <a:srgbClr val="FAF8F4"/>
-                      </a:solidFill>
-                    </a:lnT>
-                    <a:lnR w="0" cap="flat" cmpd="sng" algn="ctr">
-                      <a:solidFill>
-                        <a:srgbClr val="FAF8F4"/>
-                      </a:solidFill>
-                    </a:lnR>
-                    <a:lnL w="0" cap="flat" cmpd="sng" algn="ctr">
-                      <a:solidFill>
-                        <a:srgbClr val="FAF8F4"/>
-                      </a:solidFill>
-                    </a:lnL>
-                    <a:noFill/>
-                  </a:tcPr>
-                </a:tc>
-                <a:tc>
-                  <a:txBody>
-                    <a:bodyPr wrap="square"/>
-                    <a:lstStyle/>
-                    <a:p>
-                      <a:pPr>
-                        <a:lnSpc>
-                          <a:spcPct val="134000"/>
-                        </a:lnSpc>
-                      </a:pPr>
-                      <a:r>
-                        <a:rPr sz="1100" b="0">
-                          <a:solidFill>
-                            <a:srgbClr val="111111"/>
-                          </a:solidFill>
-                          <a:latin typeface="Poppins"/>
-                        </a:rPr>
-                        <a:t>Included</a:t>
                       </a:r>
                     </a:p>
                   </a:txBody>
@@ -16660,7 +16200,7 @@
                 </a:solidFill>
                 <a:latin typeface="Poppins"/>
               </a:rPr>
-              <a:t>Monthly in advance. Minimum three months, then stop at any review with a month's notice.</a:t>
+              <a:t>Monthly in advance. Minimum three months, then stop at any review with a month's notice. Inclusions to be confirmed.</a:t>
             </a:r>
           </a:p>
         </p:txBody>

</xml_diff>